<commit_message>
README and deck: the demo replays captured CRS sandbox pulls
The cloud desk runs CRS_PROVIDER=mock, which serves real CRS sandbox
responses captured live for all 20 personas, so no call goes to CRS during
the demo. README item 1, the stack table and the CRS sponsor line, plus the
deck's Layer 1 slide, stack row and speaker notes, now say the pulls are
replayed and that CRS_PROVIDER=crs switches to live soft pulls. The speed
slide's notes say the 62 s run used a replayed pull.

Co-Authored-By: Claude Opus 5.5 <noreply@anthropic.com>
</commit_message>
<xml_diff>
--- a/design/deck/pitch/docket-deck-v7-general.pptx
+++ b/design/deck/pitch/docket-deck-v7-general.pptx
@@ -1274,7 +1274,7 @@
           </a:p>
           <a:p>
             <a:r>
-              <a:t>IF ASKED: 62 s is one live application on the cloud desk after the CREAO fix (Oct 24 20:58): pull 1.5 s, hard stops 1.9 s, five lenders 27.7 s, reason tests 1.8 s, notice 25.8 s. Hard stops: median of 3 cloud runs, about 5 s. Most of the minute is the agents on CREAO hosting; called directly, a Claude lender answers in 2.7 s. Under load, 20 applications at once finished in about 2.5 minutes. Human figure: Bankrate, personal loan approval timelines.</a:t>
+              <a:t>IF ASKED: 62 s is one live application on the cloud desk after the CREAO fix (Oct 24 20:58): pull 1.5 s, hard stops 1.9 s, five lenders 27.7 s, reason tests 1.8 s, notice 25.8 s. The pull replayed saved CRS sandbox responses; a live pull takes about 3 s. Hard stops: median of 3 cloud runs, about 5 s. Most of the minute is the agents on CREAO hosting; called directly, a Claude lender answers in 2.7 s. Under load, 20 applications at once finished in about 2.5 minutes. Human figure: Bankrate, personal loan approval timelines.</a:t>
             </a:r>
           </a:p>
         </p:txBody>
@@ -1854,12 +1854,12 @@
           <a:lstStyle/>
           <a:p>
             <a:r>
-              <a:t>HIDDEN IN THE GENERAL VERSION (the demo runs on the six-layer slide). (B) 'That pulled your file from the CRS Credit API sandbox: TransUnion, Equifax, Experian, identity, fraud. Soft pull. Your name, address and SSN never reach a model.'</a:t>
-            </a:r>
-          </a:p>
-          <a:p>
-            <a:r>
-              <a:t>IF ASKED: convex/crs.ts (live sandbox) and convex/pii.ts (allowlist projection, tested). 20 personas captured in convex/fixtures/crs. The sandbox's TransUnion product returns VantageScore 4; the UI says 'TransUnion score'. Fields: credit.fico9, utilization, inquiries6mo, vantage4, flags.frozen, identity.verified, flags.deceased, fraud.score, flags.bankruptcy, flags.eviction, flags.lienOrJudgment.</a:t>
+              <a:t>HIDDEN IN THE GENERAL VERSION (the demo runs on the six-layer slide). (B) 'That is your file from the CRS Credit API sandbox: TransUnion, Equifax, Experian, identity, fraud. Real sandbox responses, replayed for the demo; live pulls are one setting away. Your name, address and SSN never reach a model.'</a:t>
+            </a:r>
+          </a:p>
+          <a:p>
+            <a:r>
+              <a:t>IF ASKED: convex/crs.ts and convex/pii.ts (allowlist projection, tested). The demo replays real CRS sandbox responses, captured live for all 20 personas on Oct 24 (convex/fixtures/crs). CRS_PROVIDER=crs switches to live soft pulls, about 3 s per persona, and the borrower's score doesn't move. The sandbox's TransUnion product returns VantageScore 4; the UI says 'TransUnion score'. Fields: credit.fico9, utilization, inquiries6mo, vantage4, flags.frozen, identity.verified, flags.deceased, fraud.score, flags.bankruptcy, flags.eviction, flags.lienOrJudgment.</a:t>
             </a:r>
           </a:p>
         </p:txBody>
@@ -19838,7 +19838,7 @@
                           </a:solidFill>
                           <a:latin typeface="Arial"/>
                         </a:rPr>
-                        <a:t>One soft pull. No name, address, ZIP or SSN ever reaches a model.</a:t>
+                        <a:t>Real CRS sandbox data, replayed. No name, address, ZIP or SSN ever reaches a model.</a:t>
                       </a:r>
                     </a:p>
                   </a:txBody>
@@ -21215,7 +21215,7 @@
                 </a:solidFill>
                 <a:latin typeface="Arial"/>
               </a:rPr>
-              <a:t>Layer 1: one soft pull from the CRS Credit API gives every lender the same file, and the file an agent sees has no identity in it.</a:t>
+              <a:t>Layer 1: every lender gets the same CRS Credit API sandbox file, and the file an agent sees has no identity in it.</a:t>
             </a:r>
           </a:p>
         </p:txBody>
@@ -22215,7 +22215,7 @@
                 </a:solidFill>
                 <a:latin typeface="Arial"/>
               </a:rPr>
-              <a:t>Same file for every lender, no identity in it, in about 3 seconds, and the borrower's score doesn't move.</a:t>
+              <a:t>Same file for every lender, no identity in it. The demo replays real CRS sandbox pulls; live pulls are one setting away.</a:t>
             </a:r>
           </a:p>
         </p:txBody>

</xml_diff>

<commit_message>
Pitch deck: carry the team's Drive edits into the build
Two wording edits were made directly in the Drive copies of v7: the cover
tagline ("One loan officer leveraging a desk of agents.") and the business
slide's closing line ("every new customer is just a policy file."). The build
now produces both, so docket-deck-vF.pptx in Drive matches the repo.

Co-Authored-By: Claude Opus 5.5 <noreply@anthropic.com>
</commit_message>
<xml_diff>
--- a/design/deck/pitch/docket-deck-v7-general.pptx
+++ b/design/deck/pitch/docket-deck-v7-general.pptx
@@ -834,7 +834,7 @@
           <a:lstStyle/>
           <a:p>
             <a:r>
-              <a:t>0:00 (A) Docket is a one-person credit union: one loan officer leading a whole lending desk of agents. And every reason in a denial letter is tested.</a:t>
+              <a:t>0:00 (A) Docket is a one-person credit union: one loan officer leveraging a desk of agents. And every reason in a denial letter is tested.</a:t>
             </a:r>
           </a:p>
         </p:txBody>
@@ -5357,7 +5357,7 @@
                 </a:solidFill>
                 <a:latin typeface="Arial"/>
               </a:rPr>
-              <a:t>One loan officer leading a whole lending desk of agents.</a:t>
+              <a:t>One loan officer leveraging a desk of agents.</a:t>
             </a:r>
           </a:p>
         </p:txBody>
@@ -19071,7 +19071,7 @@
                 </a:solidFill>
                 <a:latin typeface="Arial"/>
               </a:rPr>
-              <a:t>Cents to run, dollars to sell, and every new customer is a policy file, not a rebuild.</a:t>
+              <a:t>Cents to run, dollars to sell, and every new customer is just a policy file.</a:t>
             </a:r>
           </a:p>
         </p:txBody>

</xml_diff>